<commit_message>
QA visivo del deck: corretti spaziature e refusi
Rasterizzate tutte e 41 le slide (soffice, pdftoppm) e riviste una per una.

- Slide titolo: la riga con nome e affiliazione ora si allinea al centro
  del logo Sapienza, prima stava 8 px piu' in alto.
- Riquadri di codice (Zoom e Moodle, classificazione 1/2 e 2/2, bozza
  R007): il bordo inferiore distava 14 px dal filetto del footer, ora 34.
- "Le quattro esigenze": riscritto il terzo bullet per evitare il "2"
  isolato a capo.
- Accento mancante in "venerdi" dentro il JSON di esempio.
- "la aggiorna" diventa "l'aggiorna" nella slide Manutenzione.

Aggiunto lo zip dello snapshot al gitignore.

Co-Authored-By: Claude Opus 5 (1M context) <noreply@anthropic.com>
Claude-Session: https://claude.ai/code/session_01K9yYzCVZ1tPcvQmY4sbLhJ
</commit_message>
<xml_diff>
--- a/slides/Lezione_15_settembre_Agenti_AI_PromoPA.pptx
+++ b/slides/Lezione_15_settembre_Agenti_AI_PromoPA.pptx
@@ -7099,7 +7099,7 @@
         </p:nvSpPr>
         <p:spPr>
           <a:xfrm>
-            <a:off x="2700000" y="3760000"/>
+            <a:off x="2700000" y="3835000"/>
             <a:ext cx="6200000" cy="420000"/>
           </a:xfrm>
           <a:prstGeom prst="rect">
@@ -8060,7 +8060,7 @@
                 </a:solidFill>
                 <a:latin typeface="Arial"/>
               </a:rPr>
-              <a:t>Ordine consigliato: 1, 3, 4, poi 2</a:t>
+              <a:t>Ordine consigliato: prima 1, 3 e 4, poi la 2</a:t>
             </a:r>
           </a:p>
         </p:txBody>
@@ -8359,7 +8359,7 @@
         <p:spPr>
           <a:xfrm>
             <a:off x="4486320" y="1150000"/>
-            <a:ext cx="4477680" cy="3380000"/>
+            <a:ext cx="4477680" cy="3200000"/>
           </a:xfrm>
           <a:prstGeom prst="rect">
             <a:avLst/>
@@ -8689,7 +8689,7 @@
         <p:spPr>
           <a:xfrm>
             <a:off x="4662000" y="1150000"/>
-            <a:ext cx="4302000" cy="3380000"/>
+            <a:ext cx="4302000" cy="3200000"/>
           </a:xfrm>
           <a:prstGeom prst="rect">
             <a:avLst/>
@@ -9031,7 +9031,7 @@
         <p:spPr>
           <a:xfrm>
             <a:off x="4837680" y="1150000"/>
-            <a:ext cx="4126320" cy="3380000"/>
+            <a:ext cx="4126320" cy="3200000"/>
           </a:xfrm>
           <a:prstGeom prst="rect">
             <a:avLst/>
@@ -9167,7 +9167,7 @@
                 </a:solidFill>
                 <a:latin typeface="Courier New"/>
               </a:rPr>
-              <a:t>    entro venerdi"</a:t>
+              <a:t>    entro venerdì"</a:t>
             </a:r>
           </a:p>
           <a:p>
@@ -9782,7 +9782,7 @@
         <p:spPr>
           <a:xfrm>
             <a:off x="180000" y="1150000"/>
-            <a:ext cx="8784000" cy="3400000"/>
+            <a:ext cx="8784000" cy="3200000"/>
           </a:xfrm>
           <a:prstGeom prst="rect">
             <a:avLst/>
@@ -10580,7 +10580,7 @@
                 </a:solidFill>
                 <a:latin typeface="Arial"/>
               </a:rPr>
-              <a:t>La tassonomia invecchia: nuovi corsi, nuovi ruoli. Qualcuno la possiede e la aggiorna</a:t>
+              <a:t>La tassonomia invecchia: nuovi corsi, nuovi ruoli. Qualcuno la possiede e l'aggiorna</a:t>
             </a:r>
           </a:p>
           <a:p>

</xml_diff>